<commit_message>
Presentation: the talk with the new plan (B: SWOT and storage, RQ2 and RQ3; C: forecast and system, RQ4)
Slides 14, 15, 17, 18 and 19 changed; the PowerPoint has no speaker notes;
slide pictures, PDF and the title list are updated.
</commit_message>
<xml_diff>
--- a/site/assets/docs/swot-tank-tracker-proposal-talk.pptx
+++ b/site/assets/docs/swot-tank-tracker-proposal-talk.pptx
@@ -127,7 +127,7 @@
   <p:extLst>
     <p:ext uri="{521415D9-36F7-43E2-AB2F-B90AF26B5E84}">
       <p14:sectionLst xmlns:p14="http://schemas.microsoft.com/office/powerpoint/2010/main">
-        <p14:section name="Introduction" id="{58285f1d-be3d-a84f-afed-f8c45c056ebf}">
+        <p14:section name="Introduction" id="{3f6419a0-d7b3-caf8-cefb-36542fd2a945}">
           <p14:sldIdLst>
             <p14:sldId id="256"/>
             <p14:sldId id="257"/>
@@ -135,28 +135,28 @@
             <p14:sldId id="259"/>
           </p14:sldIdLst>
         </p14:section>
-        <p14:section name="The satellites" id="{36f4b2e8-185e-836f-ec15-7966a2d9b702}">
+        <p14:section name="The satellites" id="{6341b1b3-8d9f-6374-326b-68f42ca05fc6}">
           <p14:sldIdLst>
             <p14:sldId id="260"/>
             <p14:sldId id="261"/>
             <p14:sldId id="262"/>
           </p14:sldIdLst>
         </p14:section>
-        <p14:section name="Study and method" id="{605ca566-8139-aeb0-cd9a-e187ddfe1808}">
+        <p14:section name="Study and method" id="{cec30c08-7fc8-29b7-d9d6-6d1ed1a64b5b}">
           <p14:sldIdLst>
             <p14:sldId id="263"/>
             <p14:sldId id="264"/>
             <p14:sldId id="265"/>
           </p14:sldIdLst>
         </p14:section>
-        <p14:section name="Evidence" id="{43a5f231-0145-a545-a9d9-e158ade9b0b2}">
+        <p14:section name="Evidence" id="{d575cb99-b694-f74a-3146-9f6fea1ed83d}">
           <p14:sldIdLst>
             <p14:sldId id="266"/>
             <p14:sldId id="267"/>
             <p14:sldId id="268"/>
           </p14:sldIdLst>
         </p14:section>
-        <p14:section name="Plan" id="{a4f3036b-b7c9-19e6-eefd-33bf7911b125}">
+        <p14:section name="Plan" id="{370aa6a0-fe83-f063-c81c-f39cb5cfa854}">
           <p14:sldIdLst>
             <p14:sldId id="269"/>
             <p14:sldId id="270"/>
@@ -8094,7 +8094,7 @@
                   <a:schemeClr val="tx1"/>
                 </a:solidFill>
               </a:rPr>
-              <a:t>How accurate is SWOT on reservoirs and village tanks, and can a learned model tell which readings to trust better than SWOT's own flags?</a:t>
+              <a:t>How accurate is SWOT on reservoirs and village tanks, and how many "suspect" readings can a learned screen keep?</a:t>
             </a:r>
             <a:endParaRPr lang="en-US" sz="1600" dirty="0"/>
           </a:p>
@@ -8130,7 +8130,7 @@
                   <a:schemeClr val="accent6"/>
                 </a:solidFill>
               </a:rPr>
-              <a:t>Measured by error in cm against gauges, on reservoirs the model never saw</a:t>
+              <a:t>Measured by error in cm against gauges, on reservoirs the screen never saw</a:t>
             </a:r>
             <a:endParaRPr lang="en-US" sz="1150" dirty="0"/>
           </a:p>
@@ -8257,7 +8257,7 @@
                   <a:schemeClr val="tx1"/>
                 </a:solidFill>
               </a:rPr>
-              <a:t>Does AI water area plus SWOT height give storage close to official and measured values?</a:t>
+              <a:t>Can a model trained on about 100 gauged reservoirs turn SWOT height and water area into % full, for tanks it never saw?</a:t>
             </a:r>
             <a:endParaRPr lang="en-US" sz="1600" dirty="0"/>
           </a:p>
@@ -8293,7 +8293,7 @@
                   <a:schemeClr val="accent6"/>
                 </a:solidFill>
               </a:rPr>
-              <a:t>Measured by error as a % of capacity</a:t>
+              <a:t>Measured by error in % of capacity, on reservoirs it never saw</a:t>
             </a:r>
             <a:endParaRPr lang="en-US" sz="1150" dirty="0"/>
           </a:p>
@@ -8600,7 +8600,7 @@
                   <a:schemeClr val="accent6"/>
                 </a:solidFill>
               </a:rPr>
-              <a:t>Each of us owns a research question from start to finish, and trains one model for it.</a:t>
+              <a:t>Three models in one chain: A finds where the water is, B how much there is, and C what comes next.</a:t>
             </a:r>
             <a:endParaRPr lang="en-US" sz="1400" dirty="0"/>
           </a:p>
@@ -8967,7 +8967,7 @@
                   <a:schemeClr val="tx1"/>
                 </a:solidFill>
               </a:rPr>
-              <a:t>water maps for all tanks</a:t>
+              <a:t>the water area of every tank</a:t>
             </a:r>
             <a:endParaRPr lang="en-US" sz="1250" dirty="0"/>
           </a:p>
@@ -9125,7 +9125,7 @@
                 <a:ea typeface="+mj-lt" pitchFamily="34" charset="-122"/>
                 <a:cs typeface="+mj-lt" pitchFamily="34" charset="-120"/>
               </a:rPr>
-              <a:t>SWOT and gauges</a:t>
+              <a:t>SWOT and storage</a:t>
             </a:r>
             <a:endParaRPr lang="en-US" sz="1900" dirty="0"/>
           </a:p>
@@ -9196,7 +9196,70 @@
       </p:sp>
       <p:sp>
         <p:nvSpPr>
-          <p:cNvPr id="21" name="Text 17"/>
+          <p:cNvPr id="21" name="RQ3"/>
+          <p:cNvSpPr/>
+          <p:nvPr/>
+        </p:nvSpPr>
+        <p:spPr>
+          <a:xfrm>
+            <a:off x="5347106" y="2926080"/>
+            <a:ext cx="640080" cy="310896"/>
+          </a:xfrm>
+          <a:prstGeom prst="roundRect">
+            <a:avLst>
+              <a:gd name="adj" fmla="val 23529"/>
+            </a:avLst>
+          </a:prstGeom>
+          <a:solidFill>
+            <a:schemeClr val="accent3"/>
+          </a:solidFill>
+          <a:ln w="12700">
+            <a:solidFill>
+              <a:schemeClr val="accent3"/>
+            </a:solidFill>
+            <a:prstDash val="solid"/>
+          </a:ln>
+        </p:spPr>
+      </p:sp>
+      <p:sp>
+        <p:nvSpPr>
+          <p:cNvPr id="22" name="Text 18"/>
+          <p:cNvSpPr txBox="1"/>
+          <p:nvPr/>
+        </p:nvSpPr>
+        <p:spPr>
+          <a:xfrm>
+            <a:off x="5347106" y="2926080"/>
+            <a:ext cx="640080" cy="310896"/>
+          </a:xfrm>
+          <a:prstGeom prst="rect">
+            <a:avLst/>
+          </a:prstGeom>
+          <a:noFill/>
+          <a:ln/>
+        </p:spPr>
+        <p:txBody>
+          <a:bodyPr wrap="square" lIns="0" tIns="0" rIns="0" bIns="0" rtlCol="0" anchor="ctr"/>
+          <a:lstStyle/>
+          <a:p>
+            <a:pPr algn="ctr" indent="0" marL="0">
+              <a:buNone/>
+            </a:pPr>
+            <a:r>
+              <a:rPr lang="en-US" sz="1200" b="1" dirty="0">
+                <a:solidFill>
+                  <a:schemeClr val="bg1"/>
+                </a:solidFill>
+              </a:rPr>
+              <a:t>RQ3</a:t>
+            </a:r>
+            <a:endParaRPr lang="en-US" sz="1200" dirty="0"/>
+          </a:p>
+        </p:txBody>
+      </p:sp>
+      <p:sp>
+        <p:nvSpPr>
+          <p:cNvPr id="23" name="Text 19"/>
           <p:cNvSpPr txBox="1"/>
           <p:nvPr/>
         </p:nvSpPr>
@@ -9228,7 +9291,7 @@
                   <a:schemeClr val="tx1"/>
                 </a:solidFill>
               </a:rPr>
-              <a:t>SWOT heights from Hydrocron, checked against gauges</a:t>
+              <a:t>SWOT heights, checked against gauges</a:t>
             </a:r>
             <a:endParaRPr lang="en-US" sz="1400" dirty="0"/>
           </a:p>
@@ -9246,7 +9309,7 @@
                   <a:schemeClr val="tx1"/>
                 </a:solidFill>
               </a:rPr>
-              <a:t>Gauge data: daily records and history</a:t>
+              <a:t>A trust screen that cleans every reading</a:t>
             </a:r>
             <a:endParaRPr lang="en-US" sz="1400" dirty="0"/>
           </a:p>
@@ -9264,7 +9327,7 @@
                   <a:schemeClr val="tx1"/>
                 </a:solidFill>
               </a:rPr>
-              <a:t>Model: a SWOT trust model (gradient boosting)</a:t>
+              <a:t>Model: % full from height and area (gradient boosting)</a:t>
             </a:r>
             <a:endParaRPr lang="en-US" sz="1400" dirty="0"/>
           </a:p>
@@ -9272,7 +9335,7 @@
       </p:sp>
       <p:sp>
         <p:nvSpPr>
-          <p:cNvPr id="22" name="divider"/>
+          <p:cNvPr id="24" name="divider"/>
           <p:cNvSpPr/>
           <p:nvPr/>
         </p:nvSpPr>
@@ -9295,7 +9358,7 @@
       </p:sp>
       <p:sp>
         <p:nvSpPr>
-          <p:cNvPr id="23" name="Text 19"/>
+          <p:cNvPr id="25" name="Text 21"/>
           <p:cNvSpPr txBox="1"/>
           <p:nvPr/>
         </p:nvSpPr>
@@ -9334,7 +9397,7 @@
                   <a:schemeClr val="tx1"/>
                 </a:solidFill>
               </a:rPr>
-              <a:t>accuracy report and trust model</a:t>
+              <a:t>how full every tank is</a:t>
             </a:r>
             <a:endParaRPr lang="en-US" sz="1250" dirty="0"/>
           </a:p>
@@ -9342,7 +9405,7 @@
       </p:sp>
       <p:sp>
         <p:nvSpPr>
-          <p:cNvPr id="24" name="MEMBER C"/>
+          <p:cNvPr id="26" name="MEMBER C"/>
           <p:cNvSpPr/>
           <p:nvPr/>
         </p:nvSpPr>
@@ -9376,7 +9439,7 @@
       </p:sp>
       <p:sp>
         <p:nvSpPr>
-          <p:cNvPr id="25" name="icon FaChartLine"/>
+          <p:cNvPr id="27" name="icon FaChartLine"/>
           <p:cNvSpPr/>
           <p:nvPr/>
         </p:nvSpPr>
@@ -9401,7 +9464,7 @@
       </p:sp>
       <p:pic>
         <p:nvPicPr>
-          <p:cNvPr id="26" name="Image 2" descr="preencoded.png">    </p:cNvPr>
+          <p:cNvPr id="28" name="Image 2" descr="preencoded.png">    </p:cNvPr>
           <p:cNvPicPr>
             <a:picLocks noChangeAspect="1"/>
           </p:cNvPicPr>
@@ -9425,7 +9488,7 @@
       </p:pic>
       <p:sp>
         <p:nvSpPr>
-          <p:cNvPr id="27" name="Text 22"/>
+          <p:cNvPr id="29" name="Text 24"/>
           <p:cNvSpPr txBox="1"/>
           <p:nvPr/>
         </p:nvSpPr>
@@ -9461,7 +9524,7 @@
       </p:sp>
       <p:sp>
         <p:nvSpPr>
-          <p:cNvPr id="28" name="Text 23"/>
+          <p:cNvPr id="30" name="Text 25"/>
           <p:cNvSpPr txBox="1"/>
           <p:nvPr/>
         </p:nvSpPr>
@@ -9492,7 +9555,7 @@
                 <a:ea typeface="+mj-lt" pitchFamily="34" charset="-122"/>
                 <a:cs typeface="+mj-lt" pitchFamily="34" charset="-120"/>
               </a:rPr>
-              <a:t>Storage and forecast</a:t>
+              <a:t>Forecast and system</a:t>
             </a:r>
             <a:endParaRPr lang="en-US" sz="1900" dirty="0"/>
           </a:p>
@@ -9500,7 +9563,7 @@
       </p:sp>
       <p:sp>
         <p:nvSpPr>
-          <p:cNvPr id="29" name="RQ3"/>
+          <p:cNvPr id="31" name="RQ4"/>
           <p:cNvSpPr/>
           <p:nvPr/>
         </p:nvSpPr>
@@ -9527,76 +9590,13 @@
       </p:sp>
       <p:sp>
         <p:nvSpPr>
-          <p:cNvPr id="30" name="Text 25"/>
+          <p:cNvPr id="32" name="Text 27"/>
           <p:cNvSpPr txBox="1"/>
           <p:nvPr/>
         </p:nvSpPr>
         <p:spPr>
           <a:xfrm>
             <a:off x="8371637" y="2926080"/>
-            <a:ext cx="640080" cy="310896"/>
-          </a:xfrm>
-          <a:prstGeom prst="rect">
-            <a:avLst/>
-          </a:prstGeom>
-          <a:noFill/>
-          <a:ln/>
-        </p:spPr>
-        <p:txBody>
-          <a:bodyPr wrap="square" lIns="0" tIns="0" rIns="0" bIns="0" rtlCol="0" anchor="ctr"/>
-          <a:lstStyle/>
-          <a:p>
-            <a:pPr algn="ctr" indent="0" marL="0">
-              <a:buNone/>
-            </a:pPr>
-            <a:r>
-              <a:rPr lang="en-US" sz="1200" b="1" dirty="0">
-                <a:solidFill>
-                  <a:schemeClr val="bg1"/>
-                </a:solidFill>
-              </a:rPr>
-              <a:t>RQ3</a:t>
-            </a:r>
-            <a:endParaRPr lang="en-US" sz="1200" dirty="0"/>
-          </a:p>
-        </p:txBody>
-      </p:sp>
-      <p:sp>
-        <p:nvSpPr>
-          <p:cNvPr id="31" name="RQ4"/>
-          <p:cNvSpPr/>
-          <p:nvPr/>
-        </p:nvSpPr>
-        <p:spPr>
-          <a:xfrm>
-            <a:off x="9121445" y="2926080"/>
-            <a:ext cx="640080" cy="310896"/>
-          </a:xfrm>
-          <a:prstGeom prst="roundRect">
-            <a:avLst>
-              <a:gd name="adj" fmla="val 23529"/>
-            </a:avLst>
-          </a:prstGeom>
-          <a:solidFill>
-            <a:schemeClr val="accent2"/>
-          </a:solidFill>
-          <a:ln w="12700">
-            <a:solidFill>
-              <a:schemeClr val="accent2"/>
-            </a:solidFill>
-            <a:prstDash val="solid"/>
-          </a:ln>
-        </p:spPr>
-      </p:sp>
-      <p:sp>
-        <p:nvSpPr>
-          <p:cNvPr id="32" name="Text 27"/>
-          <p:cNvSpPr txBox="1"/>
-          <p:nvPr/>
-        </p:nvSpPr>
-        <p:spPr>
-          <a:xfrm>
-            <a:off x="9121445" y="2926080"/>
             <a:ext cx="640080" cy="310896"/>
           </a:xfrm>
           <a:prstGeom prst="rect">
@@ -9658,7 +9658,7 @@
                   <a:schemeClr val="tx1"/>
                 </a:solidFill>
               </a:rPr>
-              <a:t>Height–area–volume curve for each tank</a:t>
+              <a:t>Daily storage of 117 reservoirs, rain and evaporation</a:t>
             </a:r>
             <a:endParaRPr lang="en-US" sz="1400" dirty="0"/>
           </a:p>
@@ -9676,7 +9676,7 @@
                   <a:schemeClr val="tx1"/>
                 </a:solidFill>
               </a:rPr>
-              <a:t>Storage every 5–12 days, checked against official figures</a:t>
+              <a:t>The chain from picture to forecast, after every pass</a:t>
             </a:r>
             <a:endParaRPr lang="en-US" sz="1400" dirty="0"/>
           </a:p>
@@ -9764,7 +9764,7 @@
                   <a:schemeClr val="tx1"/>
                 </a:solidFill>
               </a:rPr>
-              <a:t>storage, forecast and dashboard</a:t>
+              <a:t>the forecast and the dashboard</a:t>
             </a:r>
             <a:endParaRPr lang="en-US" sz="1250" dirty="0"/>
           </a:p>
@@ -10732,7 +10732,7 @@
                   <a:schemeClr val="tx1"/>
                 </a:solidFill>
               </a:rPr>
-              <a:t>Member B: SWOT and gauges</a:t>
+              <a:t>Member B: SWOT and storage</a:t>
             </a:r>
             <a:endParaRPr lang="en-US" sz="3400" dirty="0"/>
           </a:p>
@@ -10803,14 +10803,41 @@
       </p:sp>
       <p:sp>
         <p:nvSpPr>
-          <p:cNvPr id="5" name="Text 3"/>
-          <p:cNvSpPr txBox="1"/>
-          <p:nvPr/>
-        </p:nvSpPr>
-        <p:spPr>
-          <a:xfrm>
-            <a:off x="1389888" y="1161288"/>
-            <a:ext cx="10253167" cy="411480"/>
+          <p:cNvPr id="5" name="RQ3"/>
+          <p:cNvSpPr/>
+          <p:nvPr/>
+        </p:nvSpPr>
+        <p:spPr>
+          <a:xfrm>
+            <a:off x="1298448" y="1207008"/>
+            <a:ext cx="640080" cy="310896"/>
+          </a:xfrm>
+          <a:prstGeom prst="roundRect">
+            <a:avLst>
+              <a:gd name="adj" fmla="val 23529"/>
+            </a:avLst>
+          </a:prstGeom>
+          <a:solidFill>
+            <a:schemeClr val="accent3"/>
+          </a:solidFill>
+          <a:ln w="12700">
+            <a:solidFill>
+              <a:schemeClr val="accent3"/>
+            </a:solidFill>
+            <a:prstDash val="solid"/>
+          </a:ln>
+        </p:spPr>
+      </p:sp>
+      <p:sp>
+        <p:nvSpPr>
+          <p:cNvPr id="6" name="Text 4"/>
+          <p:cNvSpPr txBox="1"/>
+          <p:nvPr/>
+        </p:nvSpPr>
+        <p:spPr>
+          <a:xfrm>
+            <a:off x="1298448" y="1207008"/>
+            <a:ext cx="640080" cy="310896"/>
           </a:xfrm>
           <a:prstGeom prst="rect">
             <a:avLst/>
@@ -10822,6 +10849,42 @@
           <a:bodyPr wrap="square" lIns="0" tIns="0" rIns="0" bIns="0" rtlCol="0" anchor="ctr"/>
           <a:lstStyle/>
           <a:p>
+            <a:pPr algn="ctr" indent="0" marL="0">
+              <a:buNone/>
+            </a:pPr>
+            <a:r>
+              <a:rPr lang="en-US" sz="1200" b="1" dirty="0">
+                <a:solidFill>
+                  <a:schemeClr val="bg1"/>
+                </a:solidFill>
+              </a:rPr>
+              <a:t>RQ3</a:t>
+            </a:r>
+            <a:endParaRPr lang="en-US" sz="1200" dirty="0"/>
+          </a:p>
+        </p:txBody>
+      </p:sp>
+      <p:sp>
+        <p:nvSpPr>
+          <p:cNvPr id="7" name="Text 5"/>
+          <p:cNvSpPr txBox="1"/>
+          <p:nvPr/>
+        </p:nvSpPr>
+        <p:spPr>
+          <a:xfrm>
+            <a:off x="2139696" y="1161288"/>
+            <a:ext cx="9503359" cy="411480"/>
+          </a:xfrm>
+          <a:prstGeom prst="rect">
+            <a:avLst/>
+          </a:prstGeom>
+          <a:noFill/>
+          <a:ln/>
+        </p:spPr>
+        <p:txBody>
+          <a:bodyPr wrap="square" lIns="0" tIns="0" rIns="0" bIns="0" rtlCol="0" anchor="ctr"/>
+          <a:lstStyle/>
+          <a:p>
             <a:pPr indent="0" marL="0">
               <a:buNone/>
             </a:pPr>
@@ -10831,7 +10894,7 @@
                   <a:schemeClr val="accent6"/>
                 </a:solidFill>
               </a:rPr>
-              <a:t>How accurate is SWOT on reservoirs and village tanks, and can a learned model tell which readings to trust better than SWOT's own flags?</a:t>
+              <a:t>How accurate is SWOT, and can a model trained on about 100 reservoirs turn SWOT height and water area into % full for new tanks?</a:t>
             </a:r>
             <a:endParaRPr lang="en-US" sz="1400" dirty="0"/>
           </a:p>
@@ -10839,7 +10902,7 @@
       </p:sp>
       <p:sp>
         <p:nvSpPr>
-          <p:cNvPr id="6" name="Data analysis"/>
+          <p:cNvPr id="8" name="Data analysis"/>
           <p:cNvSpPr/>
           <p:nvPr/>
         </p:nvSpPr>
@@ -10866,7 +10929,7 @@
       </p:sp>
       <p:sp>
         <p:nvSpPr>
-          <p:cNvPr id="7" name="icon FaChartColumn"/>
+          <p:cNvPr id="9" name="icon FaChartColumn"/>
           <p:cNvSpPr/>
           <p:nvPr/>
         </p:nvSpPr>
@@ -10891,7 +10954,7 @@
       </p:sp>
       <p:pic>
         <p:nvPicPr>
-          <p:cNvPr id="8" name="Image 0" descr="preencoded.png">    </p:cNvPr>
+          <p:cNvPr id="10" name="Image 0" descr="preencoded.png">    </p:cNvPr>
           <p:cNvPicPr>
             <a:picLocks noChangeAspect="1"/>
           </p:cNvPicPr>
@@ -10915,7 +10978,7 @@
       </p:pic>
       <p:sp>
         <p:nvSpPr>
-          <p:cNvPr id="9" name="Text 6"/>
+          <p:cNvPr id="11" name="Text 8"/>
           <p:cNvSpPr txBox="1"/>
           <p:nvPr/>
         </p:nvSpPr>
@@ -10954,7 +11017,7 @@
       </p:sp>
       <p:sp>
         <p:nvSpPr>
-          <p:cNvPr id="10" name="Text 7"/>
+          <p:cNvPr id="12" name="Text 9"/>
           <p:cNvSpPr txBox="1"/>
           <p:nvPr/>
         </p:nvSpPr>
@@ -10986,7 +11049,7 @@
                   <a:schemeClr val="tx1"/>
                 </a:solidFill>
               </a:rPr>
-              <a:t>SWOT minus gauge on every pass: the average gap and the spread in cm</a:t>
+              <a:t>SWOT minus gauge on every pass: the steady gap and the spread in cm</a:t>
             </a:r>
             <a:endParaRPr lang="en-US" sz="1500" dirty="0"/>
           </a:p>
@@ -11004,7 +11067,7 @@
                   <a:schemeClr val="tx1"/>
                 </a:solidFill>
               </a:rPr>
-              <a:t>Labels for the model: each reading's error at the 117 department reservoirs</a:t>
+              <a:t>Trust screen: how many "suspect" readings it keeps, and their error</a:t>
             </a:r>
             <a:endParaRPr lang="en-US" sz="1500" dirty="0"/>
           </a:p>
@@ -11022,7 +11085,7 @@
                   <a:schemeClr val="tx1"/>
                 </a:solidFill>
               </a:rPr>
-              <a:t>The trust model against SWOT's own flags, on reservoirs it never saw</a:t>
+              <a:t>Training pairs: daily storage with SWOT height and water area, at about 100 reservoirs</a:t>
             </a:r>
             <a:endParaRPr lang="en-US" sz="1500" dirty="0"/>
           </a:p>
@@ -11040,7 +11103,7 @@
                   <a:schemeClr val="tx1"/>
                 </a:solidFill>
               </a:rPr>
-              <a:t>How a height error turns into a volume error</a:t>
+              <a:t>Storage error in % of capacity on reservoirs the model never saw, against one formula and Imbulana's equation</a:t>
             </a:r>
             <a:endParaRPr lang="en-US" sz="1500" dirty="0"/>
           </a:p>
@@ -11048,7 +11111,7 @@
       </p:sp>
       <p:sp>
         <p:nvSpPr>
-          <p:cNvPr id="11" name="Technical work"/>
+          <p:cNvPr id="13" name="Technical work"/>
           <p:cNvSpPr/>
           <p:nvPr/>
         </p:nvSpPr>
@@ -11082,7 +11145,7 @@
       </p:sp>
       <p:sp>
         <p:nvSpPr>
-          <p:cNvPr id="12" name="icon FaGears"/>
+          <p:cNvPr id="14" name="icon FaGears"/>
           <p:cNvSpPr/>
           <p:nvPr/>
         </p:nvSpPr>
@@ -11107,7 +11170,7 @@
       </p:sp>
       <p:pic>
         <p:nvPicPr>
-          <p:cNvPr id="13" name="Image 1" descr="preencoded.png">    </p:cNvPr>
+          <p:cNvPr id="15" name="Image 1" descr="preencoded.png">    </p:cNvPr>
           <p:cNvPicPr>
             <a:picLocks noChangeAspect="1"/>
           </p:cNvPicPr>
@@ -11131,7 +11194,7 @@
       </p:pic>
       <p:sp>
         <p:nvSpPr>
-          <p:cNvPr id="14" name="Text 10"/>
+          <p:cNvPr id="16" name="Text 12"/>
           <p:cNvSpPr txBox="1"/>
           <p:nvPr/>
         </p:nvSpPr>
@@ -11170,7 +11233,7 @@
       </p:sp>
       <p:sp>
         <p:nvSpPr>
-          <p:cNvPr id="15" name="Text 11"/>
+          <p:cNvPr id="17" name="Text 13"/>
           <p:cNvSpPr txBox="1"/>
           <p:nvPr/>
         </p:nvSpPr>
@@ -11220,7 +11283,7 @@
                   <a:schemeClr val="tx1"/>
                 </a:solidFill>
               </a:rPr>
-              <a:t>Trust model: gradient boosting (XGBoost or LightGBM) on SWOT's quality fields, track distance, lake size and season</a:t>
+              <a:t>Trust screen: gradient boosting on SWOT's quality fields, track distance, lake size and season</a:t>
             </a:r>
             <a:endParaRPr lang="en-US" sz="1500" dirty="0"/>
           </a:p>
@@ -11238,7 +11301,7 @@
                   <a:schemeClr val="tx1"/>
                 </a:solidFill>
               </a:rPr>
-              <a:t>Gauge zero in metres above sea level: full supply level minus full supply depth</a:t>
+              <a:t>Storage model: gradient boosting in which more height or area never means less water</a:t>
             </a:r>
             <a:endParaRPr lang="en-US" sz="1500" dirty="0"/>
           </a:p>
@@ -11256,7 +11319,7 @@
                   <a:schemeClr val="tx1"/>
                 </a:solidFill>
               </a:rPr>
-              <a:t>Daily logger for the department's sheet; storage history turned back into gauge heights</a:t>
+              <a:t>Inputs every tank has: height, area, outline, catchment and slope (Copernicus DEM)</a:t>
             </a:r>
             <a:endParaRPr lang="en-US" sz="1500" dirty="0"/>
           </a:p>
@@ -11264,7 +11327,7 @@
       </p:sp>
       <p:sp>
         <p:nvSpPr>
-          <p:cNvPr id="16" name="output"/>
+          <p:cNvPr id="18" name="output"/>
           <p:cNvSpPr/>
           <p:nvPr/>
         </p:nvSpPr>
@@ -11291,7 +11354,7 @@
       </p:sp>
       <p:sp>
         <p:nvSpPr>
-          <p:cNvPr id="17" name="icon FaFlagCheckered"/>
+          <p:cNvPr id="19" name="icon FaFlagCheckered"/>
           <p:cNvSpPr/>
           <p:nvPr/>
         </p:nvSpPr>
@@ -11316,7 +11379,7 @@
       </p:sp>
       <p:pic>
         <p:nvPicPr>
-          <p:cNvPr id="18" name="Image 2" descr="preencoded.png">    </p:cNvPr>
+          <p:cNvPr id="20" name="Image 2" descr="preencoded.png">    </p:cNvPr>
           <p:cNvPicPr>
             <a:picLocks noChangeAspect="1"/>
           </p:cNvPicPr>
@@ -11340,7 +11403,7 @@
       </p:pic>
       <p:sp>
         <p:nvSpPr>
-          <p:cNvPr id="19" name="Text 14"/>
+          <p:cNvPr id="21" name="Text 16"/>
           <p:cNvSpPr txBox="1"/>
           <p:nvPr/>
         </p:nvSpPr>
@@ -11379,7 +11442,7 @@
                   <a:schemeClr val="bg1"/>
                 </a:solidFill>
               </a:rPr>
-              <a:t>SWOT accuracy report, the fixed gap for each reservoir, and a trust model that scores every reading</a:t>
+              <a:t>SWOT accuracy report, a screen that cleans every reading, and a model that says how full any tank is</a:t>
             </a:r>
             <a:endParaRPr lang="en-US" sz="1500" dirty="0"/>
           </a:p>
@@ -11487,7 +11550,7 @@
                   <a:schemeClr val="tx1"/>
                 </a:solidFill>
               </a:rPr>
-              <a:t>Member C: Storage and forecast</a:t>
+              <a:t>Member C: Forecast and system</a:t>
             </a:r>
             <a:endParaRPr lang="en-US" sz="3400" dirty="0"/>
           </a:p>
@@ -11495,7 +11558,7 @@
       </p:sp>
       <p:sp>
         <p:nvSpPr>
-          <p:cNvPr id="3" name="RQ3"/>
+          <p:cNvPr id="3" name="RQ4"/>
           <p:cNvSpPr/>
           <p:nvPr/>
         </p:nvSpPr>
@@ -11550,7 +11613,7 @@
                   <a:schemeClr val="bg1"/>
                 </a:solidFill>
               </a:rPr>
-              <a:t>RQ3</a:t>
+              <a:t>RQ4</a:t>
             </a:r>
             <a:endParaRPr lang="en-US" sz="1200" dirty="0"/>
           </a:p>
@@ -11558,19 +11621,80 @@
       </p:sp>
       <p:sp>
         <p:nvSpPr>
-          <p:cNvPr id="5" name="RQ4"/>
+          <p:cNvPr id="5" name="Text 3"/>
+          <p:cNvSpPr txBox="1"/>
+          <p:nvPr/>
+        </p:nvSpPr>
+        <p:spPr>
+          <a:xfrm>
+            <a:off x="1389888" y="1161288"/>
+            <a:ext cx="10253167" cy="411480"/>
+          </a:xfrm>
+          <a:prstGeom prst="rect">
+            <a:avLst/>
+          </a:prstGeom>
+          <a:noFill/>
+          <a:ln/>
+        </p:spPr>
+        <p:txBody>
+          <a:bodyPr wrap="square" lIns="0" tIns="0" rIns="0" bIns="0" rtlCol="0" anchor="ctr"/>
+          <a:lstStyle/>
+          <a:p>
+            <a:pPr indent="0" marL="0">
+              <a:buNone/>
+            </a:pPr>
+            <a:r>
+              <a:rPr lang="en-US" sz="1400" dirty="0">
+                <a:solidFill>
+                  <a:schemeClr val="accent6"/>
+                </a:solidFill>
+              </a:rPr>
+              <a:t>Can a deep-learning model forecast each tank's storage 2–4 weeks ahead, from recent storage, rain and evaporation, better than "no change"?</a:t>
+            </a:r>
+            <a:endParaRPr lang="en-US" sz="1400" dirty="0"/>
+          </a:p>
+        </p:txBody>
+      </p:sp>
+      <p:sp>
+        <p:nvSpPr>
+          <p:cNvPr id="6" name="Data analysis"/>
           <p:cNvSpPr/>
           <p:nvPr/>
         </p:nvSpPr>
         <p:spPr>
           <a:xfrm>
-            <a:off x="1298448" y="1207008"/>
-            <a:ext cx="640080" cy="310896"/>
+            <a:off x="548640" y="1783080"/>
+            <a:ext cx="5410048" cy="3611880"/>
           </a:xfrm>
           <a:prstGeom prst="roundRect">
             <a:avLst>
-              <a:gd name="adj" fmla="val 23529"/>
+              <a:gd name="adj" fmla="val 3038"/>
             </a:avLst>
+          </a:prstGeom>
+          <a:solidFill>
+            <a:schemeClr val="bg2"/>
+          </a:solidFill>
+          <a:ln w="9525">
+            <a:solidFill>
+              <a:schemeClr val="bg2"/>
+            </a:solidFill>
+            <a:prstDash val="solid"/>
+          </a:ln>
+        </p:spPr>
+      </p:sp>
+      <p:sp>
+        <p:nvSpPr>
+          <p:cNvPr id="7" name="icon FaChartColumn"/>
+          <p:cNvSpPr/>
+          <p:nvPr/>
+        </p:nvSpPr>
+        <p:spPr>
+          <a:xfrm>
+            <a:off x="822960" y="1947672"/>
+            <a:ext cx="457200" cy="457200"/>
+          </a:xfrm>
+          <a:prstGeom prst="ellipse">
+            <a:avLst/>
           </a:prstGeom>
           <a:solidFill>
             <a:schemeClr val="accent2"/>
@@ -11583,133 +11707,9 @@
           </a:ln>
         </p:spPr>
       </p:sp>
-      <p:sp>
-        <p:nvSpPr>
-          <p:cNvPr id="6" name="Text 4"/>
-          <p:cNvSpPr txBox="1"/>
-          <p:nvPr/>
-        </p:nvSpPr>
-        <p:spPr>
-          <a:xfrm>
-            <a:off x="1298448" y="1207008"/>
-            <a:ext cx="640080" cy="310896"/>
-          </a:xfrm>
-          <a:prstGeom prst="rect">
-            <a:avLst/>
-          </a:prstGeom>
-          <a:noFill/>
-          <a:ln/>
-        </p:spPr>
-        <p:txBody>
-          <a:bodyPr wrap="square" lIns="0" tIns="0" rIns="0" bIns="0" rtlCol="0" anchor="ctr"/>
-          <a:lstStyle/>
-          <a:p>
-            <a:pPr algn="ctr" indent="0" marL="0">
-              <a:buNone/>
-            </a:pPr>
-            <a:r>
-              <a:rPr lang="en-US" sz="1200" b="1" dirty="0">
-                <a:solidFill>
-                  <a:schemeClr val="bg1"/>
-                </a:solidFill>
-              </a:rPr>
-              <a:t>RQ4</a:t>
-            </a:r>
-            <a:endParaRPr lang="en-US" sz="1200" dirty="0"/>
-          </a:p>
-        </p:txBody>
-      </p:sp>
-      <p:sp>
-        <p:nvSpPr>
-          <p:cNvPr id="7" name="Text 5"/>
-          <p:cNvSpPr txBox="1"/>
-          <p:nvPr/>
-        </p:nvSpPr>
-        <p:spPr>
-          <a:xfrm>
-            <a:off x="2139696" y="1161288"/>
-            <a:ext cx="9503359" cy="411480"/>
-          </a:xfrm>
-          <a:prstGeom prst="rect">
-            <a:avLst/>
-          </a:prstGeom>
-          <a:noFill/>
-          <a:ln/>
-        </p:spPr>
-        <p:txBody>
-          <a:bodyPr wrap="square" lIns="0" tIns="0" rIns="0" bIns="0" rtlCol="0" anchor="ctr"/>
-          <a:lstStyle/>
-          <a:p>
-            <a:pPr indent="0" marL="0">
-              <a:buNone/>
-            </a:pPr>
-            <a:r>
-              <a:rPr lang="en-US" sz="1400" dirty="0">
-                <a:solidFill>
-                  <a:schemeClr val="accent6"/>
-                </a:solidFill>
-              </a:rPr>
-              <a:t>Does AI water area plus SWOT height give storage close to official values, and can a deep-learning model forecast it 2–4 weeks ahead?</a:t>
-            </a:r>
-            <a:endParaRPr lang="en-US" sz="1400" dirty="0"/>
-          </a:p>
-        </p:txBody>
-      </p:sp>
-      <p:sp>
-        <p:nvSpPr>
-          <p:cNvPr id="8" name="Data analysis"/>
-          <p:cNvSpPr/>
-          <p:nvPr/>
-        </p:nvSpPr>
-        <p:spPr>
-          <a:xfrm>
-            <a:off x="548640" y="1783080"/>
-            <a:ext cx="5410048" cy="3611880"/>
-          </a:xfrm>
-          <a:prstGeom prst="roundRect">
-            <a:avLst>
-              <a:gd name="adj" fmla="val 3038"/>
-            </a:avLst>
-          </a:prstGeom>
-          <a:solidFill>
-            <a:schemeClr val="bg2"/>
-          </a:solidFill>
-          <a:ln w="9525">
-            <a:solidFill>
-              <a:schemeClr val="bg2"/>
-            </a:solidFill>
-            <a:prstDash val="solid"/>
-          </a:ln>
-        </p:spPr>
-      </p:sp>
-      <p:sp>
-        <p:nvSpPr>
-          <p:cNvPr id="9" name="icon FaChartColumn"/>
-          <p:cNvSpPr/>
-          <p:nvPr/>
-        </p:nvSpPr>
-        <p:spPr>
-          <a:xfrm>
-            <a:off x="822960" y="1947672"/>
-            <a:ext cx="457200" cy="457200"/>
-          </a:xfrm>
-          <a:prstGeom prst="ellipse">
-            <a:avLst/>
-          </a:prstGeom>
-          <a:solidFill>
-            <a:schemeClr val="accent2"/>
-          </a:solidFill>
-          <a:ln w="12700">
-            <a:solidFill>
-              <a:schemeClr val="accent2"/>
-            </a:solidFill>
-            <a:prstDash val="solid"/>
-          </a:ln>
-        </p:spPr>
-      </p:sp>
       <p:pic>
         <p:nvPicPr>
-          <p:cNvPr id="10" name="Image 0" descr="preencoded.png">    </p:cNvPr>
+          <p:cNvPr id="8" name="Image 0" descr="preencoded.png">    </p:cNvPr>
           <p:cNvPicPr>
             <a:picLocks noChangeAspect="1"/>
           </p:cNvPicPr>
@@ -11733,7 +11733,7 @@
       </p:pic>
       <p:sp>
         <p:nvSpPr>
-          <p:cNvPr id="11" name="Text 8"/>
+          <p:cNvPr id="9" name="Text 6"/>
           <p:cNvSpPr txBox="1"/>
           <p:nvPr/>
         </p:nvSpPr>
@@ -11772,7 +11772,7 @@
       </p:sp>
       <p:sp>
         <p:nvSpPr>
-          <p:cNvPr id="12" name="Text 9"/>
+          <p:cNvPr id="10" name="Text 7"/>
           <p:cNvSpPr txBox="1"/>
           <p:nvPr/>
         </p:nvSpPr>
@@ -11804,7 +11804,7 @@
                   <a:schemeClr val="tx1"/>
                 </a:solidFill>
               </a:rPr>
-              <a:t>Each tank's area–height curve A(h) from its dots</a:t>
+              <a:t>Seasonal average for each tank, from past years only</a:t>
             </a:r>
             <a:endParaRPr lang="en-US" sz="1500" dirty="0"/>
           </a:p>
@@ -11822,7 +11822,7 @@
                   <a:schemeClr val="tx1"/>
                 </a:solidFill>
               </a:rPr>
-              <a:t>Storage change against the department's daily storage</a:t>
+              <a:t>Forecast error at 1, 2 and 4 weeks, against "no change" and the seasonal average</a:t>
             </a:r>
             <a:endParaRPr lang="en-US" sz="1500" dirty="0"/>
           </a:p>
@@ -11840,7 +11840,7 @@
                   <a:schemeClr val="tx1"/>
                 </a:solidFill>
               </a:rPr>
-              <a:t>Test the method on Kanhindawewa's drone table, and against Imbulana's formula</a:t>
+              <a:t>Tested on years and reservoirs the model never saw</a:t>
             </a:r>
             <a:endParaRPr lang="en-US" sz="1500" dirty="0"/>
           </a:p>
@@ -11858,7 +11858,7 @@
                   <a:schemeClr val="tx1"/>
                 </a:solidFill>
               </a:rPr>
-              <a:t>Forecast error at 1, 2 and 4 weeks, against "no change" and the seasonal average</a:t>
+              <a:t>The whole chain, picture to forecast, at the village tanks and on Kanhindawewa's drone survey</a:t>
             </a:r>
             <a:endParaRPr lang="en-US" sz="1500" dirty="0"/>
           </a:p>
@@ -11866,7 +11866,7 @@
       </p:sp>
       <p:sp>
         <p:nvSpPr>
-          <p:cNvPr id="13" name="Technical work"/>
+          <p:cNvPr id="11" name="Technical work"/>
           <p:cNvSpPr/>
           <p:nvPr/>
         </p:nvSpPr>
@@ -11900,7 +11900,7 @@
       </p:sp>
       <p:sp>
         <p:nvSpPr>
-          <p:cNvPr id="14" name="icon FaGears"/>
+          <p:cNvPr id="12" name="icon FaGears"/>
           <p:cNvSpPr/>
           <p:nvPr/>
         </p:nvSpPr>
@@ -11925,7 +11925,7 @@
       </p:sp>
       <p:pic>
         <p:nvPicPr>
-          <p:cNvPr id="15" name="Image 1" descr="preencoded.png">    </p:cNvPr>
+          <p:cNvPr id="13" name="Image 1" descr="preencoded.png">    </p:cNvPr>
           <p:cNvPicPr>
             <a:picLocks noChangeAspect="1"/>
           </p:cNvPicPr>
@@ -11949,7 +11949,7 @@
       </p:pic>
       <p:sp>
         <p:nvSpPr>
-          <p:cNvPr id="16" name="Text 12"/>
+          <p:cNvPr id="14" name="Text 10"/>
           <p:cNvSpPr txBox="1"/>
           <p:nvPr/>
         </p:nvSpPr>
@@ -11988,7 +11988,7 @@
       </p:sp>
       <p:sp>
         <p:nvSpPr>
-          <p:cNvPr id="17" name="Text 13"/>
+          <p:cNvPr id="15" name="Text 11"/>
           <p:cNvSpPr txBox="1"/>
           <p:nvPr/>
         </p:nvSpPr>
@@ -12020,7 +12020,7 @@
                   <a:schemeClr val="tx1"/>
                 </a:solidFill>
               </a:rPr>
-              <a:t>Storage engine: dots, curve, thin layers and safe limits, after every pass</a:t>
+              <a:t>Forecast model: an LSTM with a gradient-boosting baseline, trained on 117 reservoirs' daily storage (2020–2026), rain and evaporation</a:t>
             </a:r>
             <a:endParaRPr lang="en-US" sz="1500" dirty="0"/>
           </a:p>
@@ -12038,7 +12038,7 @@
                   <a:schemeClr val="tx1"/>
                 </a:solidFill>
               </a:rPr>
-              <a:t>Forecast model: an LSTM with a gradient-boosting baseline, trained on 117 reservoirs' daily storage (2020–2026), rain and evaporation</a:t>
+              <a:t>The chain after every pass: A's water map and SWOT's height go into B's model</a:t>
             </a:r>
             <a:endParaRPr lang="en-US" sz="1500" dirty="0"/>
           </a:p>
@@ -12082,7 +12082,7 @@
       </p:sp>
       <p:sp>
         <p:nvSpPr>
-          <p:cNvPr id="18" name="output"/>
+          <p:cNvPr id="16" name="output"/>
           <p:cNvSpPr/>
           <p:nvPr/>
         </p:nvSpPr>
@@ -12109,7 +12109,7 @@
       </p:sp>
       <p:sp>
         <p:nvSpPr>
-          <p:cNvPr id="19" name="icon FaFlagCheckered"/>
+          <p:cNvPr id="17" name="icon FaFlagCheckered"/>
           <p:cNvSpPr/>
           <p:nvPr/>
         </p:nvSpPr>
@@ -12134,7 +12134,7 @@
       </p:sp>
       <p:pic>
         <p:nvPicPr>
-          <p:cNvPr id="20" name="Image 2" descr="preencoded.png">    </p:cNvPr>
+          <p:cNvPr id="18" name="Image 2" descr="preencoded.png">    </p:cNvPr>
           <p:cNvPicPr>
             <a:picLocks noChangeAspect="1"/>
           </p:cNvPicPr>
@@ -12158,7 +12158,7 @@
       </p:pic>
       <p:sp>
         <p:nvSpPr>
-          <p:cNvPr id="21" name="Text 16"/>
+          <p:cNvPr id="19" name="Text 14"/>
           <p:cNvSpPr txBox="1"/>
           <p:nvPr/>
         </p:nvSpPr>
@@ -12197,7 +12197,7 @@
                   <a:schemeClr val="bg1"/>
                 </a:solidFill>
               </a:rPr>
-              <a:t>storage for every tank with safe limits, and a 2–4 week forecast, on a dashboard</a:t>
+              <a:t>a 2–4 week forecast for every tank, the running chain and the dashboard</a:t>
             </a:r>
             <a:endParaRPr lang="en-US" sz="1500" dirty="0"/>
           </a:p>
@@ -12475,7 +12475,7 @@
                   <a:schemeClr val="tx1"/>
                 </a:solidFill>
               </a:rPr>
-              <a:t>A SWOT trust model that scores every reading</a:t>
+              <a:t>A SWOT trust screen, and a model that turns height and area into % full</a:t>
             </a:r>
             <a:endParaRPr lang="en-US" sz="1600" dirty="0"/>
           </a:p>
@@ -12560,7 +12560,7 @@
                   <a:schemeClr val="tx1"/>
                 </a:solidFill>
               </a:rPr>
-              <a:t>Curves and storage every 5–12 days for all 13 tanks</a:t>
+              <a:t>Storage every 5–12 days for all 13 tanks</a:t>
             </a:r>
             <a:endParaRPr lang="en-US" sz="1600" dirty="0"/>
           </a:p>
@@ -13080,7 +13080,7 @@
                   <a:schemeClr val="accent6"/>
                 </a:solidFill>
               </a:rPr>
-              <a:t>Labelled data, gauge readings, and the three models: water map, trust model, forecast</a:t>
+              <a:t>Labelled data, gauge readings, and the three models: water map, storage model, forecast</a:t>
             </a:r>
             <a:endParaRPr lang="en-US" sz="1250" dirty="0"/>
           </a:p>

</xml_diff>

<commit_message>
Presentation: the final slides
RQ3 is compared with one formula for all tanks (no Imbulana), slide 2 counts the tanks on its map, slide 19 waits only for the name check, and slide 20 adds the Global Water Watch archive, the Copernicus elevation map and IMERG for daily rain. New PowerPoint (no speaker notes), PDF and slide pictures.
</commit_message>
<xml_diff>
--- a/site/assets/docs/swot-tank-tracker-proposal-talk.pptx
+++ b/site/assets/docs/swot-tank-tracker-proposal-talk.pptx
@@ -127,7 +127,7 @@
   <p:extLst>
     <p:ext uri="{521415D9-36F7-43E2-AB2F-B90AF26B5E84}">
       <p14:sectionLst xmlns:p14="http://schemas.microsoft.com/office/powerpoint/2010/main">
-        <p14:section name="Introduction" id="{3f6419a0-d7b3-caf8-cefb-36542fd2a945}">
+        <p14:section name="Introduction" id="{f81e3bdb-39ac-99b7-357a-9393e33d6931}">
           <p14:sldIdLst>
             <p14:sldId id="256"/>
             <p14:sldId id="257"/>
@@ -135,28 +135,28 @@
             <p14:sldId id="259"/>
           </p14:sldIdLst>
         </p14:section>
-        <p14:section name="The satellites" id="{6341b1b3-8d9f-6374-326b-68f42ca05fc6}">
+        <p14:section name="The satellites" id="{db251148-a154-e12f-6825-9dda8b65ed1c}">
           <p14:sldIdLst>
             <p14:sldId id="260"/>
             <p14:sldId id="261"/>
             <p14:sldId id="262"/>
           </p14:sldIdLst>
         </p14:section>
-        <p14:section name="Study and method" id="{cec30c08-7fc8-29b7-d9d6-6d1ed1a64b5b}">
+        <p14:section name="Study and method" id="{50a27b4f-4321-fbca-c55d-b142010bbaeb}">
           <p14:sldIdLst>
             <p14:sldId id="263"/>
             <p14:sldId id="264"/>
             <p14:sldId id="265"/>
           </p14:sldIdLst>
         </p14:section>
-        <p14:section name="Evidence" id="{d575cb99-b694-f74a-3146-9f6fea1ed83d}">
+        <p14:section name="Evidence" id="{91b74a35-f3f0-bee9-cf86-363ee21ce51e}">
           <p14:sldIdLst>
             <p14:sldId id="266"/>
             <p14:sldId id="267"/>
             <p14:sldId id="268"/>
           </p14:sldIdLst>
         </p14:section>
-        <p14:section name="Plan" id="{370aa6a0-fe83-f063-c81c-f39cb5cfa854}">
+        <p14:section name="Plan" id="{b7a470ed-8f5c-e574-ea44-a704798c720d}">
           <p14:sldIdLst>
             <p14:sldId id="269"/>
             <p14:sldId id="270"/>
@@ -11103,7 +11103,7 @@
                   <a:schemeClr val="tx1"/>
                 </a:solidFill>
               </a:rPr>
-              <a:t>Storage error in % of capacity on reservoirs the model never saw, against one formula and Imbulana's equation</a:t>
+              <a:t>Storage error in % of capacity on reservoirs the model never saw, against one formula for all tanks</a:t>
             </a:r>
             <a:endParaRPr lang="en-US" sz="1500" dirty="0"/>
           </a:p>
@@ -12980,7 +12980,7 @@
                   <a:schemeClr val="accent6"/>
                 </a:solidFill>
               </a:rPr>
-              <a:t>Study area confirmed after the cascade and name checks</a:t>
+              <a:t>Study area confirmed after the name check</a:t>
             </a:r>
             <a:endParaRPr lang="en-US" sz="1250" dirty="0"/>
           </a:p>
@@ -13882,7 +13882,7 @@
                   <a:schemeClr val="bg1"/>
                 </a:solidFill>
               </a:rPr>
-              <a:t>432 tanks of 6.25 ha or more in our study area (blue)</a:t>
+              <a:t>432 tanks of 6.25 ha or more on this map (blue)</a:t>
             </a:r>
             <a:endParaRPr lang="en-US" sz="1500" dirty="0"/>
           </a:p>
@@ -14564,46 +14564,7 @@
         </p:nvSpPr>
         <p:spPr>
           <a:xfrm>
-            <a:off x="6278728" y="1691640"/>
-            <a:ext cx="5364328" cy="329184"/>
-          </a:xfrm>
-          <a:prstGeom prst="rect">
-            <a:avLst/>
-          </a:prstGeom>
-          <a:noFill/>
-          <a:ln/>
-        </p:spPr>
-        <p:txBody>
-          <a:bodyPr wrap="square" lIns="0" tIns="0" rIns="0" bIns="0" rtlCol="0" anchor="ctr"/>
-          <a:lstStyle/>
-          <a:p>
-            <a:pPr indent="0" marL="0">
-              <a:buNone/>
-            </a:pPr>
-            <a:r>
-              <a:rPr lang="en-US" sz="1500" dirty="0">
-                <a:solidFill>
-                  <a:schemeClr val="tx1"/>
-                </a:solidFill>
-                <a:latin typeface="+mj-lt" pitchFamily="34" charset="0"/>
-                <a:ea typeface="+mj-lt" pitchFamily="34" charset="-122"/>
-                <a:cs typeface="+mj-lt" pitchFamily="34" charset="-120"/>
-              </a:rPr>
-              <a:t>Ground truth</a:t>
-            </a:r>
-            <a:endParaRPr lang="en-US" sz="1500" dirty="0"/>
-          </a:p>
-        </p:txBody>
-      </p:sp>
-      <p:sp>
-        <p:nvSpPr>
-          <p:cNvPr id="15" name="Text 13"/>
-          <p:cNvSpPr txBox="1"/>
-          <p:nvPr/>
-        </p:nvSpPr>
-        <p:spPr>
-          <a:xfrm>
-            <a:off x="6415888" y="2075688"/>
+            <a:off x="685800" y="5093208"/>
             <a:ext cx="5227168" cy="292608"/>
           </a:xfrm>
           <a:prstGeom prst="rect">
@@ -14632,7 +14593,7 @@
                   </a:extLst>
                 </a:hlinkClick>
               </a:rPr>
-              <a:t>Irrigation Department: reservoir water level</a:t>
+              <a:t>Global Water Watch archive</a:t>
             </a:r>
             <a:pPr indent="0" marL="0">
               <a:buNone/>
@@ -14643,7 +14604,7 @@
                   <a:schemeClr val="accent6"/>
                 </a:solidFill>
               </a:rPr>
-              <a:t>  the daily sheet</a:t>
+              <a:t>  reservoir water areas</a:t>
             </a:r>
             <a:endParaRPr lang="en-US" sz="1250" dirty="0"/>
           </a:p>
@@ -14651,13 +14612,52 @@
       </p:sp>
       <p:sp>
         <p:nvSpPr>
+          <p:cNvPr id="15" name="Text 13"/>
+          <p:cNvSpPr txBox="1"/>
+          <p:nvPr/>
+        </p:nvSpPr>
+        <p:spPr>
+          <a:xfrm>
+            <a:off x="548640" y="5550408"/>
+            <a:ext cx="5364328" cy="329184"/>
+          </a:xfrm>
+          <a:prstGeom prst="rect">
+            <a:avLst/>
+          </a:prstGeom>
+          <a:noFill/>
+          <a:ln/>
+        </p:spPr>
+        <p:txBody>
+          <a:bodyPr wrap="square" lIns="0" tIns="0" rIns="0" bIns="0" rtlCol="0" anchor="ctr"/>
+          <a:lstStyle/>
+          <a:p>
+            <a:pPr indent="0" marL="0">
+              <a:buNone/>
+            </a:pPr>
+            <a:r>
+              <a:rPr lang="en-US" sz="1500" dirty="0">
+                <a:solidFill>
+                  <a:schemeClr val="tx1"/>
+                </a:solidFill>
+                <a:latin typeface="+mj-lt" pitchFamily="34" charset="0"/>
+                <a:ea typeface="+mj-lt" pitchFamily="34" charset="-122"/>
+                <a:cs typeface="+mj-lt" pitchFamily="34" charset="-120"/>
+              </a:rPr>
+              <a:t>Ground shape</a:t>
+            </a:r>
+            <a:endParaRPr lang="en-US" sz="1500" dirty="0"/>
+          </a:p>
+        </p:txBody>
+      </p:sp>
+      <p:sp>
+        <p:nvSpPr>
           <p:cNvPr id="16" name="Text 14"/>
           <p:cNvSpPr txBox="1"/>
           <p:nvPr/>
         </p:nvSpPr>
         <p:spPr>
           <a:xfrm>
-            <a:off x="6415888" y="2386584"/>
+            <a:off x="685800" y="5934456"/>
             <a:ext cx="5227168" cy="292608"/>
           </a:xfrm>
           <a:prstGeom prst="rect">
@@ -14686,7 +14686,7 @@
                   </a:extLst>
                 </a:hlinkClick>
               </a:rPr>
-              <a:t>Irrigation Department: reservoir status</a:t>
+              <a:t>Copernicus DEM (GLO-30)</a:t>
             </a:r>
             <a:pPr indent="0" marL="0">
               <a:buNone/>
@@ -14697,7 +14697,7 @@
                   <a:schemeClr val="accent6"/>
                 </a:solidFill>
               </a:rPr>
-              <a:t>  web page</a:t>
+              <a:t>  30 m elevation map</a:t>
             </a:r>
             <a:endParaRPr lang="en-US" sz="1250" dirty="0"/>
           </a:p>
@@ -14711,7 +14711,46 @@
         </p:nvSpPr>
         <p:spPr>
           <a:xfrm>
-            <a:off x="6415888" y="2697480"/>
+            <a:off x="6278728" y="1691640"/>
+            <a:ext cx="5364328" cy="329184"/>
+          </a:xfrm>
+          <a:prstGeom prst="rect">
+            <a:avLst/>
+          </a:prstGeom>
+          <a:noFill/>
+          <a:ln/>
+        </p:spPr>
+        <p:txBody>
+          <a:bodyPr wrap="square" lIns="0" tIns="0" rIns="0" bIns="0" rtlCol="0" anchor="ctr"/>
+          <a:lstStyle/>
+          <a:p>
+            <a:pPr indent="0" marL="0">
+              <a:buNone/>
+            </a:pPr>
+            <a:r>
+              <a:rPr lang="en-US" sz="1500" dirty="0">
+                <a:solidFill>
+                  <a:schemeClr val="tx1"/>
+                </a:solidFill>
+                <a:latin typeface="+mj-lt" pitchFamily="34" charset="0"/>
+                <a:ea typeface="+mj-lt" pitchFamily="34" charset="-122"/>
+                <a:cs typeface="+mj-lt" pitchFamily="34" charset="-120"/>
+              </a:rPr>
+              <a:t>Ground truth</a:t>
+            </a:r>
+            <a:endParaRPr lang="en-US" sz="1500" dirty="0"/>
+          </a:p>
+        </p:txBody>
+      </p:sp>
+      <p:sp>
+        <p:nvSpPr>
+          <p:cNvPr id="18" name="Text 16"/>
+          <p:cNvSpPr txBox="1"/>
+          <p:nvPr/>
+        </p:nvSpPr>
+        <p:spPr>
+          <a:xfrm>
+            <a:off x="6415888" y="2075688"/>
             <a:ext cx="5227168" cy="292608"/>
           </a:xfrm>
           <a:prstGeom prst="rect">
@@ -14740,7 +14779,7 @@
                   </a:extLst>
                 </a:hlinkClick>
               </a:rPr>
-              <a:t>Irrigation Department: reservoir map layer</a:t>
+              <a:t>Irrigation Department: reservoir water level</a:t>
             </a:r>
             <a:pPr indent="0" marL="0">
               <a:buNone/>
@@ -14751,7 +14790,7 @@
                   <a:schemeClr val="accent6"/>
                 </a:solidFill>
               </a:rPr>
-              <a:t>  full supply levels</a:t>
+              <a:t>  the daily sheet</a:t>
             </a:r>
             <a:endParaRPr lang="en-US" sz="1250" dirty="0"/>
           </a:p>
@@ -14759,13 +14798,13 @@
       </p:sp>
       <p:sp>
         <p:nvSpPr>
-          <p:cNvPr id="18" name="Text 16"/>
-          <p:cNvSpPr txBox="1"/>
-          <p:nvPr/>
-        </p:nvSpPr>
-        <p:spPr>
-          <a:xfrm>
-            <a:off x="6415888" y="3008376"/>
+          <p:cNvPr id="19" name="Text 17"/>
+          <p:cNvSpPr txBox="1"/>
+          <p:nvPr/>
+        </p:nvSpPr>
+        <p:spPr>
+          <a:xfrm>
+            <a:off x="6415888" y="2386584"/>
             <a:ext cx="5227168" cy="292608"/>
           </a:xfrm>
           <a:prstGeom prst="rect">
@@ -14794,7 +14833,7 @@
                   </a:extLst>
                 </a:hlinkClick>
               </a:rPr>
-              <a:t>Kanhindawewa drone survey</a:t>
+              <a:t>Irrigation Department: reservoir status</a:t>
             </a:r>
             <a:pPr indent="0" marL="0">
               <a:buNone/>
@@ -14805,7 +14844,7 @@
                   <a:schemeClr val="accent6"/>
                 </a:solidFill>
               </a:rPr>
-              <a:t>  area and capacity every 1 ft (PDF)</a:t>
+              <a:t>  web page</a:t>
             </a:r>
             <a:endParaRPr lang="en-US" sz="1250" dirty="0"/>
           </a:p>
@@ -14813,13 +14852,13 @@
       </p:sp>
       <p:sp>
         <p:nvSpPr>
-          <p:cNvPr id="19" name="Text 17"/>
-          <p:cNvSpPr txBox="1"/>
-          <p:nvPr/>
-        </p:nvSpPr>
-        <p:spPr>
-          <a:xfrm>
-            <a:off x="6415888" y="3319272"/>
+          <p:cNvPr id="20" name="Text 18"/>
+          <p:cNvSpPr txBox="1"/>
+          <p:nvPr/>
+        </p:nvSpPr>
+        <p:spPr>
+          <a:xfrm>
+            <a:off x="6415888" y="2697480"/>
             <a:ext cx="5227168" cy="292608"/>
           </a:xfrm>
           <a:prstGeom prst="rect">
@@ -14848,7 +14887,7 @@
                   </a:extLst>
                 </a:hlinkClick>
               </a:rPr>
-              <a:t>Mahaweli Authority: reservoir status reports</a:t>
+              <a:t>Irrigation Department: reservoir map layer</a:t>
             </a:r>
             <a:pPr indent="0" marL="0">
               <a:buNone/>
@@ -14859,7 +14898,7 @@
                   <a:schemeClr val="accent6"/>
                 </a:solidFill>
               </a:rPr>
-              <a:t>  daily levels</a:t>
+              <a:t>  full supply levels</a:t>
             </a:r>
             <a:endParaRPr lang="en-US" sz="1250" dirty="0"/>
           </a:p>
@@ -14867,52 +14906,13 @@
       </p:sp>
       <p:sp>
         <p:nvSpPr>
-          <p:cNvPr id="20" name="Text 18"/>
-          <p:cNvSpPr txBox="1"/>
-          <p:nvPr/>
-        </p:nvSpPr>
-        <p:spPr>
-          <a:xfrm>
-            <a:off x="6278728" y="3776472"/>
-            <a:ext cx="5364328" cy="329184"/>
-          </a:xfrm>
-          <a:prstGeom prst="rect">
-            <a:avLst/>
-          </a:prstGeom>
-          <a:noFill/>
-          <a:ln/>
-        </p:spPr>
-        <p:txBody>
-          <a:bodyPr wrap="square" lIns="0" tIns="0" rIns="0" bIns="0" rtlCol="0" anchor="ctr"/>
-          <a:lstStyle/>
-          <a:p>
-            <a:pPr indent="0" marL="0">
-              <a:buNone/>
-            </a:pPr>
-            <a:r>
-              <a:rPr lang="en-US" sz="1500" dirty="0">
-                <a:solidFill>
-                  <a:schemeClr val="tx1"/>
-                </a:solidFill>
-                <a:latin typeface="+mj-lt" pitchFamily="34" charset="0"/>
-                <a:ea typeface="+mj-lt" pitchFamily="34" charset="-122"/>
-                <a:cs typeface="+mj-lt" pitchFamily="34" charset="-120"/>
-              </a:rPr>
-              <a:t>Weather (for the forecast)</a:t>
-            </a:r>
-            <a:endParaRPr lang="en-US" sz="1500" dirty="0"/>
-          </a:p>
-        </p:txBody>
-      </p:sp>
-      <p:sp>
-        <p:nvSpPr>
           <p:cNvPr id="21" name="Text 19"/>
           <p:cNvSpPr txBox="1"/>
           <p:nvPr/>
         </p:nvSpPr>
         <p:spPr>
           <a:xfrm>
-            <a:off x="6415888" y="4160520"/>
+            <a:off x="6415888" y="3008376"/>
             <a:ext cx="5227168" cy="292608"/>
           </a:xfrm>
           <a:prstGeom prst="rect">
@@ -14941,7 +14941,7 @@
                   </a:extLst>
                 </a:hlinkClick>
               </a:rPr>
-              <a:t>CHIRPS</a:t>
+              <a:t>Kanhindawewa drone survey</a:t>
             </a:r>
             <a:pPr indent="0" marL="0">
               <a:buNone/>
@@ -14952,7 +14952,7 @@
                   <a:schemeClr val="accent6"/>
                 </a:solidFill>
               </a:rPr>
-              <a:t>  daily rainfall</a:t>
+              <a:t>  area and capacity every 1 ft (PDF)</a:t>
             </a:r>
             <a:endParaRPr lang="en-US" sz="1250" dirty="0"/>
           </a:p>
@@ -14966,7 +14966,7 @@
         </p:nvSpPr>
         <p:spPr>
           <a:xfrm>
-            <a:off x="6415888" y="4471416"/>
+            <a:off x="6415888" y="3319272"/>
             <a:ext cx="5227168" cy="292608"/>
           </a:xfrm>
           <a:prstGeom prst="rect">
@@ -14995,7 +14995,7 @@
                   </a:extLst>
                 </a:hlinkClick>
               </a:rPr>
-              <a:t>ERA5</a:t>
+              <a:t>Mahaweli Authority: reservoir status reports</a:t>
             </a:r>
             <a:pPr indent="0" marL="0">
               <a:buNone/>
@@ -15006,7 +15006,7 @@
                   <a:schemeClr val="accent6"/>
                 </a:solidFill>
               </a:rPr>
-              <a:t>  weather, for evaporation</a:t>
+              <a:t>  daily levels</a:t>
             </a:r>
             <a:endParaRPr lang="en-US" sz="1250" dirty="0"/>
           </a:p>
@@ -15020,7 +15020,7 @@
         </p:nvSpPr>
         <p:spPr>
           <a:xfrm>
-            <a:off x="6278728" y="4928616"/>
+            <a:off x="6278728" y="3776472"/>
             <a:ext cx="5364328" cy="329184"/>
           </a:xfrm>
           <a:prstGeom prst="rect">
@@ -15045,6 +15045,207 @@
                 <a:ea typeface="+mj-lt" pitchFamily="34" charset="-122"/>
                 <a:cs typeface="+mj-lt" pitchFamily="34" charset="-120"/>
               </a:rPr>
+              <a:t>Weather (for the forecast)</a:t>
+            </a:r>
+            <a:endParaRPr lang="en-US" sz="1500" dirty="0"/>
+          </a:p>
+        </p:txBody>
+      </p:sp>
+      <p:sp>
+        <p:nvSpPr>
+          <p:cNvPr id="24" name="Text 22"/>
+          <p:cNvSpPr txBox="1"/>
+          <p:nvPr/>
+        </p:nvSpPr>
+        <p:spPr>
+          <a:xfrm>
+            <a:off x="6415888" y="4160520"/>
+            <a:ext cx="5227168" cy="292608"/>
+          </a:xfrm>
+          <a:prstGeom prst="rect">
+            <a:avLst/>
+          </a:prstGeom>
+          <a:noFill/>
+          <a:ln/>
+        </p:spPr>
+        <p:txBody>
+          <a:bodyPr wrap="square" lIns="0" tIns="0" rIns="0" bIns="0" rtlCol="0" anchor="ctr"/>
+          <a:lstStyle/>
+          <a:p>
+            <a:pPr indent="0" marL="0">
+              <a:buNone/>
+            </a:pPr>
+            <a:r>
+              <a:rPr lang="en-US" sz="1250" b="1" u="sng" dirty="0">
+                <a:solidFill>
+                  <a:schemeClr val="accent1"/>
+                </a:solidFill>
+                <a:hlinkClick r:id="rId16" invalidUrl="" action="" tgtFrame="" tooltip="" history="1" highlightClick="0" endSnd="0">
+                  <a:extLst>
+                    <a:ext uri="{A12FA001-AC4F-418D-AE19-62706E023703}">
+                      <ahyp:hlinkClr xmlns:ahyp="http://schemas.microsoft.com/office/drawing/2018/hyperlinkcolor" val="tx"/>
+                    </a:ext>
+                  </a:extLst>
+                </a:hlinkClick>
+              </a:rPr>
+              <a:t>GPM IMERG</a:t>
+            </a:r>
+            <a:pPr indent="0" marL="0">
+              <a:buNone/>
+            </a:pPr>
+            <a:r>
+              <a:rPr lang="en-US" sz="1250" dirty="0">
+                <a:solidFill>
+                  <a:schemeClr val="accent6"/>
+                </a:solidFill>
+              </a:rPr>
+              <a:t>  daily rainfall</a:t>
+            </a:r>
+            <a:endParaRPr lang="en-US" sz="1250" dirty="0"/>
+          </a:p>
+        </p:txBody>
+      </p:sp>
+      <p:sp>
+        <p:nvSpPr>
+          <p:cNvPr id="25" name="Text 23"/>
+          <p:cNvSpPr txBox="1"/>
+          <p:nvPr/>
+        </p:nvSpPr>
+        <p:spPr>
+          <a:xfrm>
+            <a:off x="6415888" y="4471416"/>
+            <a:ext cx="5227168" cy="292608"/>
+          </a:xfrm>
+          <a:prstGeom prst="rect">
+            <a:avLst/>
+          </a:prstGeom>
+          <a:noFill/>
+          <a:ln/>
+        </p:spPr>
+        <p:txBody>
+          <a:bodyPr wrap="square" lIns="0" tIns="0" rIns="0" bIns="0" rtlCol="0" anchor="ctr"/>
+          <a:lstStyle/>
+          <a:p>
+            <a:pPr indent="0" marL="0">
+              <a:buNone/>
+            </a:pPr>
+            <a:r>
+              <a:rPr lang="en-US" sz="1250" b="1" u="sng" dirty="0">
+                <a:solidFill>
+                  <a:schemeClr val="accent1"/>
+                </a:solidFill>
+                <a:hlinkClick r:id="rId17" invalidUrl="" action="" tgtFrame="" tooltip="" history="1" highlightClick="0" endSnd="0">
+                  <a:extLst>
+                    <a:ext uri="{A12FA001-AC4F-418D-AE19-62706E023703}">
+                      <ahyp:hlinkClr xmlns:ahyp="http://schemas.microsoft.com/office/drawing/2018/hyperlinkcolor" val="tx"/>
+                    </a:ext>
+                  </a:extLst>
+                </a:hlinkClick>
+              </a:rPr>
+              <a:t>CHIRPS</a:t>
+            </a:r>
+            <a:pPr indent="0" marL="0">
+              <a:buNone/>
+            </a:pPr>
+            <a:r>
+              <a:rPr lang="en-US" sz="1250" dirty="0">
+                <a:solidFill>
+                  <a:schemeClr val="accent6"/>
+                </a:solidFill>
+              </a:rPr>
+              <a:t>  monthly rainfall checks</a:t>
+            </a:r>
+            <a:endParaRPr lang="en-US" sz="1250" dirty="0"/>
+          </a:p>
+        </p:txBody>
+      </p:sp>
+      <p:sp>
+        <p:nvSpPr>
+          <p:cNvPr id="26" name="Text 24"/>
+          <p:cNvSpPr txBox="1"/>
+          <p:nvPr/>
+        </p:nvSpPr>
+        <p:spPr>
+          <a:xfrm>
+            <a:off x="6415888" y="4782312"/>
+            <a:ext cx="5227168" cy="292608"/>
+          </a:xfrm>
+          <a:prstGeom prst="rect">
+            <a:avLst/>
+          </a:prstGeom>
+          <a:noFill/>
+          <a:ln/>
+        </p:spPr>
+        <p:txBody>
+          <a:bodyPr wrap="square" lIns="0" tIns="0" rIns="0" bIns="0" rtlCol="0" anchor="ctr"/>
+          <a:lstStyle/>
+          <a:p>
+            <a:pPr indent="0" marL="0">
+              <a:buNone/>
+            </a:pPr>
+            <a:r>
+              <a:rPr lang="en-US" sz="1250" b="1" u="sng" dirty="0">
+                <a:solidFill>
+                  <a:schemeClr val="accent1"/>
+                </a:solidFill>
+                <a:hlinkClick r:id="rId18" invalidUrl="" action="" tgtFrame="" tooltip="" history="1" highlightClick="0" endSnd="0">
+                  <a:extLst>
+                    <a:ext uri="{A12FA001-AC4F-418D-AE19-62706E023703}">
+                      <ahyp:hlinkClr xmlns:ahyp="http://schemas.microsoft.com/office/drawing/2018/hyperlinkcolor" val="tx"/>
+                    </a:ext>
+                  </a:extLst>
+                </a:hlinkClick>
+              </a:rPr>
+              <a:t>ERA5</a:t>
+            </a:r>
+            <a:pPr indent="0" marL="0">
+              <a:buNone/>
+            </a:pPr>
+            <a:r>
+              <a:rPr lang="en-US" sz="1250" dirty="0">
+                <a:solidFill>
+                  <a:schemeClr val="accent6"/>
+                </a:solidFill>
+              </a:rPr>
+              <a:t>  weather, for evaporation</a:t>
+            </a:r>
+            <a:endParaRPr lang="en-US" sz="1250" dirty="0"/>
+          </a:p>
+        </p:txBody>
+      </p:sp>
+      <p:sp>
+        <p:nvSpPr>
+          <p:cNvPr id="27" name="Text 25"/>
+          <p:cNvSpPr txBox="1"/>
+          <p:nvPr/>
+        </p:nvSpPr>
+        <p:spPr>
+          <a:xfrm>
+            <a:off x="6278728" y="5239512"/>
+            <a:ext cx="5364328" cy="329184"/>
+          </a:xfrm>
+          <a:prstGeom prst="rect">
+            <a:avLst/>
+          </a:prstGeom>
+          <a:noFill/>
+          <a:ln/>
+        </p:spPr>
+        <p:txBody>
+          <a:bodyPr wrap="square" lIns="0" tIns="0" rIns="0" bIns="0" rtlCol="0" anchor="ctr"/>
+          <a:lstStyle/>
+          <a:p>
+            <a:pPr indent="0" marL="0">
+              <a:buNone/>
+            </a:pPr>
+            <a:r>
+              <a:rPr lang="en-US" sz="1500" dirty="0">
+                <a:solidFill>
+                  <a:schemeClr val="tx1"/>
+                </a:solidFill>
+                <a:latin typeface="+mj-lt" pitchFamily="34" charset="0"/>
+                <a:ea typeface="+mj-lt" pitchFamily="34" charset="-122"/>
+                <a:cs typeface="+mj-lt" pitchFamily="34" charset="-120"/>
+              </a:rPr>
               <a:t>Our work</a:t>
             </a:r>
             <a:endParaRPr lang="en-US" sz="1500" dirty="0"/>
@@ -15053,13 +15254,13 @@
       </p:sp>
       <p:sp>
         <p:nvSpPr>
-          <p:cNvPr id="24" name="Text 22"/>
-          <p:cNvSpPr txBox="1"/>
-          <p:nvPr/>
-        </p:nvSpPr>
-        <p:spPr>
-          <a:xfrm>
-            <a:off x="6415888" y="5312664"/>
+          <p:cNvPr id="28" name="Text 26"/>
+          <p:cNvSpPr txBox="1"/>
+          <p:nvPr/>
+        </p:nvSpPr>
+        <p:spPr>
+          <a:xfrm>
+            <a:off x="6415888" y="5623560"/>
             <a:ext cx="5227168" cy="292608"/>
           </a:xfrm>
           <a:prstGeom prst="rect">
@@ -15080,7 +15281,7 @@
                 <a:solidFill>
                   <a:schemeClr val="accent1"/>
                 </a:solidFill>
-                <a:hlinkClick r:id="rId16" invalidUrl="" action="" tgtFrame="" tooltip="" history="1" highlightClick="0" endSnd="0">
+                <a:hlinkClick r:id="rId19" invalidUrl="" action="" tgtFrame="" tooltip="" history="1" highlightClick="0" endSnd="0">
                   <a:extLst>
                     <a:ext uri="{A12FA001-AC4F-418D-AE19-62706E023703}">
                       <ahyp:hlinkClr xmlns:ahyp="http://schemas.microsoft.com/office/drawing/2018/hyperlinkcolor" val="tx"/>

</xml_diff>